<commit_message>
Update to README and lectures
</commit_message>
<xml_diff>
--- a/lectures/IntroLecture1b_Smith.pptx
+++ b/lectures/IntroLecture1b_Smith.pptx
@@ -5,7 +5,7 @@
     <p:sldMasterId id="2147483648" r:id="rId1"/>
   </p:sldMasterIdLst>
   <p:notesMasterIdLst>
-    <p:notesMasterId r:id="rId14"/>
+    <p:notesMasterId r:id="rId16"/>
   </p:notesMasterIdLst>
   <p:sldIdLst>
     <p:sldId id="256" r:id="rId2"/>
@@ -20,6 +20,8 @@
     <p:sldId id="280" r:id="rId11"/>
     <p:sldId id="281" r:id="rId12"/>
     <p:sldId id="282" r:id="rId13"/>
+    <p:sldId id="2221" r:id="rId14"/>
+    <p:sldId id="2236" r:id="rId15"/>
   </p:sldIdLst>
   <p:sldSz cx="12192000" cy="6858000"/>
   <p:notesSz cx="6858000" cy="9144000"/>
@@ -208,7 +210,7 @@
           <a:p>
             <a:fld id="{FB6042CB-28A2-754D-ACCB-4F0CF49EE203}" type="datetimeFigureOut">
               <a:rPr lang="en-US" smtClean="0"/>
-              <a:t>2/26/26</a:t>
+              <a:t>3/8/26</a:t>
             </a:fld>
             <a:endParaRPr lang="en-US"/>
           </a:p>
@@ -622,7 +624,7 @@
           <a:p>
             <a:fld id="{560296B3-6EEC-114C-BC37-B0B61E99771B}" type="datetimeFigureOut">
               <a:rPr lang="en-US" smtClean="0"/>
-              <a:t>2/26/26</a:t>
+              <a:t>3/8/26</a:t>
             </a:fld>
             <a:endParaRPr lang="en-US"/>
           </a:p>
@@ -820,7 +822,7 @@
           <a:p>
             <a:fld id="{560296B3-6EEC-114C-BC37-B0B61E99771B}" type="datetimeFigureOut">
               <a:rPr lang="en-US" smtClean="0"/>
-              <a:t>2/26/26</a:t>
+              <a:t>3/8/26</a:t>
             </a:fld>
             <a:endParaRPr lang="en-US"/>
           </a:p>
@@ -1028,7 +1030,7 @@
           <a:p>
             <a:fld id="{560296B3-6EEC-114C-BC37-B0B61E99771B}" type="datetimeFigureOut">
               <a:rPr lang="en-US" smtClean="0"/>
-              <a:t>2/26/26</a:t>
+              <a:t>3/8/26</a:t>
             </a:fld>
             <a:endParaRPr lang="en-US"/>
           </a:p>
@@ -1226,7 +1228,7 @@
           <a:p>
             <a:fld id="{560296B3-6EEC-114C-BC37-B0B61E99771B}" type="datetimeFigureOut">
               <a:rPr lang="en-US" smtClean="0"/>
-              <a:t>2/26/26</a:t>
+              <a:t>3/8/26</a:t>
             </a:fld>
             <a:endParaRPr lang="en-US"/>
           </a:p>
@@ -1501,7 +1503,7 @@
           <a:p>
             <a:fld id="{560296B3-6EEC-114C-BC37-B0B61E99771B}" type="datetimeFigureOut">
               <a:rPr lang="en-US" smtClean="0"/>
-              <a:t>2/26/26</a:t>
+              <a:t>3/8/26</a:t>
             </a:fld>
             <a:endParaRPr lang="en-US"/>
           </a:p>
@@ -1766,7 +1768,7 @@
           <a:p>
             <a:fld id="{560296B3-6EEC-114C-BC37-B0B61E99771B}" type="datetimeFigureOut">
               <a:rPr lang="en-US" smtClean="0"/>
-              <a:t>2/26/26</a:t>
+              <a:t>3/8/26</a:t>
             </a:fld>
             <a:endParaRPr lang="en-US"/>
           </a:p>
@@ -2178,7 +2180,7 @@
           <a:p>
             <a:fld id="{560296B3-6EEC-114C-BC37-B0B61E99771B}" type="datetimeFigureOut">
               <a:rPr lang="en-US" smtClean="0"/>
-              <a:t>2/26/26</a:t>
+              <a:t>3/8/26</a:t>
             </a:fld>
             <a:endParaRPr lang="en-US"/>
           </a:p>
@@ -2319,7 +2321,7 @@
           <a:p>
             <a:fld id="{560296B3-6EEC-114C-BC37-B0B61E99771B}" type="datetimeFigureOut">
               <a:rPr lang="en-US" smtClean="0"/>
-              <a:t>2/26/26</a:t>
+              <a:t>3/8/26</a:t>
             </a:fld>
             <a:endParaRPr lang="en-US"/>
           </a:p>
@@ -2432,7 +2434,7 @@
           <a:p>
             <a:fld id="{560296B3-6EEC-114C-BC37-B0B61E99771B}" type="datetimeFigureOut">
               <a:rPr lang="en-US" smtClean="0"/>
-              <a:t>2/26/26</a:t>
+              <a:t>3/8/26</a:t>
             </a:fld>
             <a:endParaRPr lang="en-US"/>
           </a:p>
@@ -2743,7 +2745,7 @@
           <a:p>
             <a:fld id="{560296B3-6EEC-114C-BC37-B0B61E99771B}" type="datetimeFigureOut">
               <a:rPr lang="en-US" smtClean="0"/>
-              <a:t>2/26/26</a:t>
+              <a:t>3/8/26</a:t>
             </a:fld>
             <a:endParaRPr lang="en-US"/>
           </a:p>
@@ -3031,7 +3033,7 @@
           <a:p>
             <a:fld id="{560296B3-6EEC-114C-BC37-B0B61E99771B}" type="datetimeFigureOut">
               <a:rPr lang="en-US" smtClean="0"/>
-              <a:t>2/26/26</a:t>
+              <a:t>3/8/26</a:t>
             </a:fld>
             <a:endParaRPr lang="en-US"/>
           </a:p>
@@ -3272,7 +3274,7 @@
           <a:p>
             <a:fld id="{560296B3-6EEC-114C-BC37-B0B61E99771B}" type="datetimeFigureOut">
               <a:rPr lang="en-US" smtClean="0"/>
-              <a:t>2/26/26</a:t>
+              <a:t>3/8/26</a:t>
             </a:fld>
             <a:endParaRPr lang="en-US"/>
           </a:p>
@@ -4732,6 +4734,399 @@
 </p:sld>
 </file>
 
+<file path=ppt/slides/slide13.xml><?xml version="1.0" encoding="utf-8"?>
+<p:sld xmlns:a="http://schemas.openxmlformats.org/drawingml/2006/main" xmlns:r="http://schemas.openxmlformats.org/officeDocument/2006/relationships" xmlns:p="http://schemas.openxmlformats.org/presentationml/2006/main">
+  <p:cSld>
+    <p:spTree>
+      <p:nvGrpSpPr>
+        <p:cNvPr id="1" name="">
+          <a:extLst>
+            <a:ext uri="{FF2B5EF4-FFF2-40B4-BE49-F238E27FC236}">
+              <a16:creationId xmlns:a16="http://schemas.microsoft.com/office/drawing/2014/main" id="{7C03DDDC-74A6-A651-9F6F-8DD7C91D212E}"/>
+            </a:ext>
+          </a:extLst>
+        </p:cNvPr>
+        <p:cNvGrpSpPr/>
+        <p:nvPr/>
+      </p:nvGrpSpPr>
+      <p:grpSpPr>
+        <a:xfrm>
+          <a:off x="0" y="0"/>
+          <a:ext cx="0" cy="0"/>
+          <a:chOff x="0" y="0"/>
+          <a:chExt cx="0" cy="0"/>
+        </a:xfrm>
+      </p:grpSpPr>
+      <p:sp>
+        <p:nvSpPr>
+          <p:cNvPr id="2" name="TextBox 1">
+            <a:extLst>
+              <a:ext uri="{FF2B5EF4-FFF2-40B4-BE49-F238E27FC236}">
+                <a16:creationId xmlns:a16="http://schemas.microsoft.com/office/drawing/2014/main" id="{5CD01262-EA5F-7642-A634-FB5B0F970F3F}"/>
+              </a:ext>
+            </a:extLst>
+          </p:cNvPr>
+          <p:cNvSpPr txBox="1"/>
+          <p:nvPr/>
+        </p:nvSpPr>
+        <p:spPr>
+          <a:xfrm>
+            <a:off x="657225" y="2533650"/>
+            <a:ext cx="10877550" cy="739754"/>
+          </a:xfrm>
+          <a:prstGeom prst="rect">
+            <a:avLst/>
+          </a:prstGeom>
+          <a:noFill/>
+        </p:spPr>
+        <p:txBody>
+          <a:bodyPr wrap="square" rtlCol="0">
+            <a:spAutoFit/>
+          </a:bodyPr>
+          <a:lstStyle/>
+          <a:p>
+            <a:pPr algn="ctr">
+              <a:lnSpc>
+                <a:spcPct val="150000"/>
+              </a:lnSpc>
+            </a:pPr>
+            <a:r>
+              <a:rPr lang="en-US" sz="3200" b="1" dirty="0">
+                <a:latin typeface="Arial" panose="020B0604020202020204" pitchFamily="34" charset="0"/>
+                <a:cs typeface="Arial" panose="020B0604020202020204" pitchFamily="34" charset="0"/>
+              </a:rPr>
+              <a:t>Poll, take 2!</a:t>
+            </a:r>
+          </a:p>
+        </p:txBody>
+      </p:sp>
+      <p:sp>
+        <p:nvSpPr>
+          <p:cNvPr id="8" name="Slide Number Placeholder 7">
+            <a:extLst>
+              <a:ext uri="{FF2B5EF4-FFF2-40B4-BE49-F238E27FC236}">
+                <a16:creationId xmlns:a16="http://schemas.microsoft.com/office/drawing/2014/main" id="{136F1D06-D99C-C088-6C32-260DD06B9F8B}"/>
+              </a:ext>
+            </a:extLst>
+          </p:cNvPr>
+          <p:cNvSpPr>
+            <a:spLocks noGrp="1"/>
+          </p:cNvSpPr>
+          <p:nvPr>
+            <p:ph type="sldNum" sz="quarter" idx="12"/>
+          </p:nvPr>
+        </p:nvSpPr>
+        <p:spPr>
+          <a:xfrm>
+            <a:off x="9263062" y="6337300"/>
+            <a:ext cx="2743200" cy="365125"/>
+          </a:xfrm>
+        </p:spPr>
+        <p:txBody>
+          <a:bodyPr/>
+          <a:lstStyle/>
+          <a:p>
+            <a:fld id="{A7C13B74-2CD1-074C-84D2-FF26F00FE39E}" type="slidenum">
+              <a:rPr lang="en-US" sz="1400" smtClean="0">
+                <a:solidFill>
+                  <a:schemeClr val="tx1"/>
+                </a:solidFill>
+              </a:rPr>
+              <a:t>13</a:t>
+            </a:fld>
+            <a:endParaRPr lang="en-US" sz="1400" dirty="0">
+              <a:solidFill>
+                <a:schemeClr val="tx1"/>
+              </a:solidFill>
+            </a:endParaRPr>
+          </a:p>
+        </p:txBody>
+      </p:sp>
+      <p:sp>
+        <p:nvSpPr>
+          <p:cNvPr id="4" name="TextBox 3">
+            <a:extLst>
+              <a:ext uri="{FF2B5EF4-FFF2-40B4-BE49-F238E27FC236}">
+                <a16:creationId xmlns:a16="http://schemas.microsoft.com/office/drawing/2014/main" id="{58803C29-ECC7-8CEC-5B5C-E56F2BF098F3}"/>
+              </a:ext>
+            </a:extLst>
+          </p:cNvPr>
+          <p:cNvSpPr txBox="1"/>
+          <p:nvPr/>
+        </p:nvSpPr>
+        <p:spPr>
+          <a:xfrm>
+            <a:off x="657225" y="3285541"/>
+            <a:ext cx="10877550" cy="598112"/>
+          </a:xfrm>
+          <a:prstGeom prst="rect">
+            <a:avLst/>
+          </a:prstGeom>
+          <a:noFill/>
+        </p:spPr>
+        <p:txBody>
+          <a:bodyPr wrap="square" rtlCol="0">
+            <a:spAutoFit/>
+          </a:bodyPr>
+          <a:lstStyle/>
+          <a:p>
+            <a:pPr algn="ctr">
+              <a:lnSpc>
+                <a:spcPct val="150000"/>
+              </a:lnSpc>
+            </a:pPr>
+            <a:r>
+              <a:rPr lang="en-US" sz="2500" dirty="0">
+                <a:solidFill>
+                  <a:srgbClr val="467886"/>
+                </a:solidFill>
+                <a:highlight>
+                  <a:srgbClr val="FFFF00"/>
+                </a:highlight>
+                <a:latin typeface="Arial" panose="020B0604020202020204" pitchFamily="34" charset="0"/>
+                <a:cs typeface="Arial" panose="020B0604020202020204" pitchFamily="34" charset="0"/>
+                <a:hlinkClick r:id="rId2">
+                  <a:extLst>
+                    <a:ext uri="{A12FA001-AC4F-418D-AE19-62706E023703}">
+                      <ahyp:hlinkClr xmlns:ahyp="http://schemas.microsoft.com/office/drawing/2018/hyperlinkcolor" val="tx"/>
+                    </a:ext>
+                  </a:extLst>
+                </a:hlinkClick>
+              </a:rPr>
+              <a:t>https://forms.gle/</a:t>
+            </a:r>
+            <a:r>
+              <a:rPr lang="en-US" sz="2500" dirty="0">
+                <a:solidFill>
+                  <a:schemeClr val="tx2">
+                    <a:lumMod val="50000"/>
+                    <a:lumOff val="50000"/>
+                  </a:schemeClr>
+                </a:solidFill>
+                <a:highlight>
+                  <a:srgbClr val="FFFF00"/>
+                </a:highlight>
+                <a:latin typeface="Arial" panose="020B0604020202020204" pitchFamily="34" charset="0"/>
+                <a:cs typeface="Arial" panose="020B0604020202020204" pitchFamily="34" charset="0"/>
+                <a:hlinkClick r:id="rId2">
+                  <a:extLst>
+                    <a:ext uri="{A12FA001-AC4F-418D-AE19-62706E023703}">
+                      <ahyp:hlinkClr xmlns:ahyp="http://schemas.microsoft.com/office/drawing/2018/hyperlinkcolor" val="tx"/>
+                    </a:ext>
+                  </a:extLst>
+                </a:hlinkClick>
+              </a:rPr>
+              <a:t>gBCuXjs6jcxfxGWw5</a:t>
+            </a:r>
+            <a:r>
+              <a:rPr lang="en-US" sz="2500" dirty="0">
+                <a:solidFill>
+                  <a:schemeClr val="tx2">
+                    <a:lumMod val="50000"/>
+                    <a:lumOff val="50000"/>
+                  </a:schemeClr>
+                </a:solidFill>
+                <a:highlight>
+                  <a:srgbClr val="FFFF00"/>
+                </a:highlight>
+                <a:latin typeface="Arial" panose="020B0604020202020204" pitchFamily="34" charset="0"/>
+                <a:cs typeface="Arial" panose="020B0604020202020204" pitchFamily="34" charset="0"/>
+              </a:rPr>
+              <a:t> </a:t>
+            </a:r>
+          </a:p>
+        </p:txBody>
+      </p:sp>
+    </p:spTree>
+    <p:extLst>
+      <p:ext uri="{BB962C8B-B14F-4D97-AF65-F5344CB8AC3E}">
+        <p14:creationId xmlns:p14="http://schemas.microsoft.com/office/powerpoint/2010/main" val="1543468140"/>
+      </p:ext>
+    </p:extLst>
+  </p:cSld>
+  <p:clrMapOvr>
+    <a:masterClrMapping/>
+  </p:clrMapOvr>
+</p:sld>
+</file>
+
+<file path=ppt/slides/slide14.xml><?xml version="1.0" encoding="utf-8"?>
+<p:sld xmlns:a="http://schemas.openxmlformats.org/drawingml/2006/main" xmlns:r="http://schemas.openxmlformats.org/officeDocument/2006/relationships" xmlns:p="http://schemas.openxmlformats.org/presentationml/2006/main">
+  <p:cSld>
+    <p:spTree>
+      <p:nvGrpSpPr>
+        <p:cNvPr id="1" name="">
+          <a:extLst>
+            <a:ext uri="{FF2B5EF4-FFF2-40B4-BE49-F238E27FC236}">
+              <a16:creationId xmlns:a16="http://schemas.microsoft.com/office/drawing/2014/main" id="{408D7A66-6EBC-3016-5218-C3DB00C7AB72}"/>
+            </a:ext>
+          </a:extLst>
+        </p:cNvPr>
+        <p:cNvGrpSpPr/>
+        <p:nvPr/>
+      </p:nvGrpSpPr>
+      <p:grpSpPr>
+        <a:xfrm>
+          <a:off x="0" y="0"/>
+          <a:ext cx="0" cy="0"/>
+          <a:chOff x="0" y="0"/>
+          <a:chExt cx="0" cy="0"/>
+        </a:xfrm>
+      </p:grpSpPr>
+      <p:sp>
+        <p:nvSpPr>
+          <p:cNvPr id="2" name="TextBox 1">
+            <a:extLst>
+              <a:ext uri="{FF2B5EF4-FFF2-40B4-BE49-F238E27FC236}">
+                <a16:creationId xmlns:a16="http://schemas.microsoft.com/office/drawing/2014/main" id="{705158DD-527E-F619-EAE7-9B224C64E00B}"/>
+              </a:ext>
+            </a:extLst>
+          </p:cNvPr>
+          <p:cNvSpPr txBox="1"/>
+          <p:nvPr/>
+        </p:nvSpPr>
+        <p:spPr>
+          <a:xfrm>
+            <a:off x="657225" y="2533650"/>
+            <a:ext cx="10877550" cy="739754"/>
+          </a:xfrm>
+          <a:prstGeom prst="rect">
+            <a:avLst/>
+          </a:prstGeom>
+          <a:noFill/>
+        </p:spPr>
+        <p:txBody>
+          <a:bodyPr wrap="square" rtlCol="0">
+            <a:spAutoFit/>
+          </a:bodyPr>
+          <a:lstStyle/>
+          <a:p>
+            <a:pPr algn="ctr">
+              <a:lnSpc>
+                <a:spcPct val="150000"/>
+              </a:lnSpc>
+            </a:pPr>
+            <a:r>
+              <a:rPr lang="en-US" sz="3200" b="1" dirty="0">
+                <a:latin typeface="Arial" panose="020B0604020202020204" pitchFamily="34" charset="0"/>
+                <a:cs typeface="Arial" panose="020B0604020202020204" pitchFamily="34" charset="0"/>
+              </a:rPr>
+              <a:t>Poll </a:t>
+            </a:r>
+            <a:r>
+              <a:rPr lang="en-US" sz="3200" b="1" dirty="0">
+                <a:highlight>
+                  <a:srgbClr val="FFFF00"/>
+                </a:highlight>
+                <a:latin typeface="Arial" panose="020B0604020202020204" pitchFamily="34" charset="0"/>
+                <a:cs typeface="Arial" panose="020B0604020202020204" pitchFamily="34" charset="0"/>
+              </a:rPr>
+              <a:t>*after Sierra’s lecture</a:t>
+            </a:r>
+          </a:p>
+        </p:txBody>
+      </p:sp>
+      <p:sp>
+        <p:nvSpPr>
+          <p:cNvPr id="8" name="Slide Number Placeholder 7">
+            <a:extLst>
+              <a:ext uri="{FF2B5EF4-FFF2-40B4-BE49-F238E27FC236}">
+                <a16:creationId xmlns:a16="http://schemas.microsoft.com/office/drawing/2014/main" id="{2070759B-ED78-9239-C973-521BE427F44D}"/>
+              </a:ext>
+            </a:extLst>
+          </p:cNvPr>
+          <p:cNvSpPr>
+            <a:spLocks noGrp="1"/>
+          </p:cNvSpPr>
+          <p:nvPr>
+            <p:ph type="sldNum" sz="quarter" idx="12"/>
+          </p:nvPr>
+        </p:nvSpPr>
+        <p:spPr>
+          <a:xfrm>
+            <a:off x="9263062" y="6337300"/>
+            <a:ext cx="2743200" cy="365125"/>
+          </a:xfrm>
+        </p:spPr>
+        <p:txBody>
+          <a:bodyPr/>
+          <a:lstStyle/>
+          <a:p>
+            <a:fld id="{A7C13B74-2CD1-074C-84D2-FF26F00FE39E}" type="slidenum">
+              <a:rPr lang="en-US" sz="1400" smtClean="0">
+                <a:solidFill>
+                  <a:schemeClr val="tx1"/>
+                </a:solidFill>
+              </a:rPr>
+              <a:t>14</a:t>
+            </a:fld>
+            <a:endParaRPr lang="en-US" sz="1400" dirty="0">
+              <a:solidFill>
+                <a:schemeClr val="tx1"/>
+              </a:solidFill>
+            </a:endParaRPr>
+          </a:p>
+        </p:txBody>
+      </p:sp>
+      <p:sp>
+        <p:nvSpPr>
+          <p:cNvPr id="4" name="TextBox 3">
+            <a:extLst>
+              <a:ext uri="{FF2B5EF4-FFF2-40B4-BE49-F238E27FC236}">
+                <a16:creationId xmlns:a16="http://schemas.microsoft.com/office/drawing/2014/main" id="{01423887-CC8E-D16D-2E31-45CEFFEFBBE2}"/>
+              </a:ext>
+            </a:extLst>
+          </p:cNvPr>
+          <p:cNvSpPr txBox="1"/>
+          <p:nvPr/>
+        </p:nvSpPr>
+        <p:spPr>
+          <a:xfrm>
+            <a:off x="657225" y="3285541"/>
+            <a:ext cx="10877550" cy="598112"/>
+          </a:xfrm>
+          <a:prstGeom prst="rect">
+            <a:avLst/>
+          </a:prstGeom>
+          <a:noFill/>
+        </p:spPr>
+        <p:txBody>
+          <a:bodyPr wrap="square" rtlCol="0">
+            <a:spAutoFit/>
+          </a:bodyPr>
+          <a:lstStyle/>
+          <a:p>
+            <a:pPr algn="ctr">
+              <a:lnSpc>
+                <a:spcPct val="150000"/>
+              </a:lnSpc>
+            </a:pPr>
+            <a:r>
+              <a:rPr lang="en-US" sz="2500" dirty="0">
+                <a:highlight>
+                  <a:srgbClr val="FFFF00"/>
+                </a:highlight>
+                <a:latin typeface="Arial" panose="020B0604020202020204" pitchFamily="34" charset="0"/>
+                <a:cs typeface="Arial" panose="020B0604020202020204" pitchFamily="34" charset="0"/>
+              </a:rPr>
+              <a:t>[teams: level of understanding now vs before]</a:t>
+            </a:r>
+          </a:p>
+        </p:txBody>
+      </p:sp>
+    </p:spTree>
+    <p:extLst>
+      <p:ext uri="{BB962C8B-B14F-4D97-AF65-F5344CB8AC3E}">
+        <p14:creationId xmlns:p14="http://schemas.microsoft.com/office/powerpoint/2010/main" val="3182914858"/>
+      </p:ext>
+    </p:extLst>
+  </p:cSld>
+  <p:clrMapOvr>
+    <a:masterClrMapping/>
+  </p:clrMapOvr>
+</p:sld>
+</file>
+
 <file path=ppt/slides/slide2.xml><?xml version="1.0" encoding="utf-8"?>
 <p:sld xmlns:a="http://schemas.openxmlformats.org/drawingml/2006/main" xmlns:r="http://schemas.openxmlformats.org/officeDocument/2006/relationships" xmlns:p="http://schemas.openxmlformats.org/presentationml/2006/main">
   <p:cSld>
@@ -4824,6 +5219,12 @@
               <a:t>Fastqc</a:t>
             </a:r>
             <a:endParaRPr lang="en-US" sz="2400" b="1" dirty="0">
+              <a:solidFill>
+                <a:schemeClr val="tx2">
+                  <a:lumMod val="50000"/>
+                  <a:lumOff val="50000"/>
+                </a:schemeClr>
+              </a:solidFill>
               <a:latin typeface="Arial" panose="020B0604020202020204" pitchFamily="34" charset="0"/>
               <a:cs typeface="Arial" panose="020B0604020202020204" pitchFamily="34" charset="0"/>
             </a:endParaRPr>
@@ -4835,50 +5236,37 @@
             </a:pPr>
             <a:r>
               <a:rPr lang="en-US" sz="2400" dirty="0">
-                <a:latin typeface="Arial" panose="020B0604020202020204" pitchFamily="34" charset="0"/>
-                <a:cs typeface="Arial" panose="020B0604020202020204" pitchFamily="34" charset="0"/>
-              </a:rPr>
-              <a:t>https://</a:t>
-            </a:r>
-            <a:r>
-              <a:rPr lang="en-US" sz="2400" dirty="0" err="1">
-                <a:latin typeface="Arial" panose="020B0604020202020204" pitchFamily="34" charset="0"/>
-                <a:cs typeface="Arial" panose="020B0604020202020204" pitchFamily="34" charset="0"/>
-              </a:rPr>
-              <a:t>github.com</a:t>
+                <a:solidFill>
+                  <a:schemeClr val="tx2">
+                    <a:lumMod val="50000"/>
+                    <a:lumOff val="50000"/>
+                  </a:schemeClr>
+                </a:solidFill>
+                <a:latin typeface="Arial" panose="020B0604020202020204" pitchFamily="34" charset="0"/>
+                <a:cs typeface="Arial" panose="020B0604020202020204" pitchFamily="34" charset="0"/>
+                <a:hlinkClick r:id="rId2">
+                  <a:extLst>
+                    <a:ext uri="{A12FA001-AC4F-418D-AE19-62706E023703}">
+                      <ahyp:hlinkClr xmlns:ahyp="http://schemas.microsoft.com/office/drawing/2018/hyperlinkcolor" val="tx"/>
+                    </a:ext>
+                  </a:extLst>
+                </a:hlinkClick>
+              </a:rPr>
+              <a:t>https://github.com/s-andrews/FastQC</a:t>
             </a:r>
             <a:r>
               <a:rPr lang="en-US" sz="2400" dirty="0">
-                <a:latin typeface="Arial" panose="020B0604020202020204" pitchFamily="34" charset="0"/>
-                <a:cs typeface="Arial" panose="020B0604020202020204" pitchFamily="34" charset="0"/>
-              </a:rPr>
-              <a:t>/s-</a:t>
-            </a:r>
-            <a:r>
-              <a:rPr lang="en-US" sz="2400" dirty="0" err="1">
-                <a:latin typeface="Arial" panose="020B0604020202020204" pitchFamily="34" charset="0"/>
-                <a:cs typeface="Arial" panose="020B0604020202020204" pitchFamily="34" charset="0"/>
-              </a:rPr>
-              <a:t>andrews</a:t>
-            </a:r>
-            <a:r>
-              <a:rPr lang="en-US" sz="2400" dirty="0">
-                <a:latin typeface="Arial" panose="020B0604020202020204" pitchFamily="34" charset="0"/>
-                <a:cs typeface="Arial" panose="020B0604020202020204" pitchFamily="34" charset="0"/>
-              </a:rPr>
-              <a:t>/</a:t>
-            </a:r>
-            <a:r>
-              <a:rPr lang="en-US" sz="2400" dirty="0" err="1">
-                <a:latin typeface="Arial" panose="020B0604020202020204" pitchFamily="34" charset="0"/>
-                <a:cs typeface="Arial" panose="020B0604020202020204" pitchFamily="34" charset="0"/>
-              </a:rPr>
-              <a:t>FastQC</a:t>
-            </a:r>
-            <a:endParaRPr lang="en-US" sz="2400" dirty="0">
-              <a:latin typeface="Arial" panose="020B0604020202020204" pitchFamily="34" charset="0"/>
-              <a:cs typeface="Arial" panose="020B0604020202020204" pitchFamily="34" charset="0"/>
-            </a:endParaRPr>
+                <a:solidFill>
+                  <a:schemeClr val="tx2">
+                    <a:lumMod val="50000"/>
+                    <a:lumOff val="50000"/>
+                  </a:schemeClr>
+                </a:solidFill>
+                <a:latin typeface="Arial" panose="020B0604020202020204" pitchFamily="34" charset="0"/>
+                <a:cs typeface="Arial" panose="020B0604020202020204" pitchFamily="34" charset="0"/>
+              </a:rPr>
+              <a:t> </a:t>
+            </a:r>
           </a:p>
           <a:p>
             <a:r>
@@ -4889,6 +5277,12 @@
               <a:t>Trim_galore</a:t>
             </a:r>
             <a:endParaRPr lang="en-US" sz="2400" b="1" dirty="0">
+              <a:solidFill>
+                <a:schemeClr val="tx2">
+                  <a:lumMod val="50000"/>
+                  <a:lumOff val="50000"/>
+                </a:schemeClr>
+              </a:solidFill>
               <a:latin typeface="Arial" panose="020B0604020202020204" pitchFamily="34" charset="0"/>
               <a:cs typeface="Arial" panose="020B0604020202020204" pitchFamily="34" charset="0"/>
             </a:endParaRPr>
@@ -4900,50 +5294,37 @@
             </a:pPr>
             <a:r>
               <a:rPr lang="en-US" sz="2400" dirty="0">
-                <a:latin typeface="Arial" panose="020B0604020202020204" pitchFamily="34" charset="0"/>
-                <a:cs typeface="Arial" panose="020B0604020202020204" pitchFamily="34" charset="0"/>
-              </a:rPr>
-              <a:t>https://</a:t>
-            </a:r>
-            <a:r>
-              <a:rPr lang="en-US" sz="2400" dirty="0" err="1">
-                <a:latin typeface="Arial" panose="020B0604020202020204" pitchFamily="34" charset="0"/>
-                <a:cs typeface="Arial" panose="020B0604020202020204" pitchFamily="34" charset="0"/>
-              </a:rPr>
-              <a:t>github.com</a:t>
+                <a:solidFill>
+                  <a:schemeClr val="tx2">
+                    <a:lumMod val="50000"/>
+                    <a:lumOff val="50000"/>
+                  </a:schemeClr>
+                </a:solidFill>
+                <a:latin typeface="Arial" panose="020B0604020202020204" pitchFamily="34" charset="0"/>
+                <a:cs typeface="Arial" panose="020B0604020202020204" pitchFamily="34" charset="0"/>
+                <a:hlinkClick r:id="rId3">
+                  <a:extLst>
+                    <a:ext uri="{A12FA001-AC4F-418D-AE19-62706E023703}">
+                      <ahyp:hlinkClr xmlns:ahyp="http://schemas.microsoft.com/office/drawing/2018/hyperlinkcolor" val="tx"/>
+                    </a:ext>
+                  </a:extLst>
+                </a:hlinkClick>
+              </a:rPr>
+              <a:t>https://github.com/FelixKrueger/TrimGalore</a:t>
             </a:r>
             <a:r>
               <a:rPr lang="en-US" sz="2400" dirty="0">
-                <a:latin typeface="Arial" panose="020B0604020202020204" pitchFamily="34" charset="0"/>
-                <a:cs typeface="Arial" panose="020B0604020202020204" pitchFamily="34" charset="0"/>
-              </a:rPr>
-              <a:t>/</a:t>
-            </a:r>
-            <a:r>
-              <a:rPr lang="en-US" sz="2400" dirty="0" err="1">
-                <a:latin typeface="Arial" panose="020B0604020202020204" pitchFamily="34" charset="0"/>
-                <a:cs typeface="Arial" panose="020B0604020202020204" pitchFamily="34" charset="0"/>
-              </a:rPr>
-              <a:t>FelixKrueger</a:t>
-            </a:r>
-            <a:r>
-              <a:rPr lang="en-US" sz="2400" dirty="0">
-                <a:latin typeface="Arial" panose="020B0604020202020204" pitchFamily="34" charset="0"/>
-                <a:cs typeface="Arial" panose="020B0604020202020204" pitchFamily="34" charset="0"/>
-              </a:rPr>
-              <a:t>/</a:t>
-            </a:r>
-            <a:r>
-              <a:rPr lang="en-US" sz="2400" dirty="0" err="1">
-                <a:latin typeface="Arial" panose="020B0604020202020204" pitchFamily="34" charset="0"/>
-                <a:cs typeface="Arial" panose="020B0604020202020204" pitchFamily="34" charset="0"/>
-              </a:rPr>
-              <a:t>TrimGalore</a:t>
-            </a:r>
-            <a:endParaRPr lang="en-US" sz="2400" dirty="0">
-              <a:latin typeface="Arial" panose="020B0604020202020204" pitchFamily="34" charset="0"/>
-              <a:cs typeface="Arial" panose="020B0604020202020204" pitchFamily="34" charset="0"/>
-            </a:endParaRPr>
+                <a:solidFill>
+                  <a:schemeClr val="tx2">
+                    <a:lumMod val="50000"/>
+                    <a:lumOff val="50000"/>
+                  </a:schemeClr>
+                </a:solidFill>
+                <a:latin typeface="Arial" panose="020B0604020202020204" pitchFamily="34" charset="0"/>
+                <a:cs typeface="Arial" panose="020B0604020202020204" pitchFamily="34" charset="0"/>
+              </a:rPr>
+              <a:t> </a:t>
+            </a:r>
           </a:p>
         </p:txBody>
       </p:sp>

</xml_diff>

<commit_message>
Minor update to lectures
</commit_message>
<xml_diff>
--- a/lectures/IntroLecture1b_Smith.pptx
+++ b/lectures/IntroLecture1b_Smith.pptx
@@ -5,7 +5,7 @@
     <p:sldMasterId id="2147483648" r:id="rId1"/>
   </p:sldMasterIdLst>
   <p:notesMasterIdLst>
-    <p:notesMasterId r:id="rId16"/>
+    <p:notesMasterId r:id="rId15"/>
   </p:notesMasterIdLst>
   <p:sldIdLst>
     <p:sldId id="256" r:id="rId2"/>
@@ -21,7 +21,6 @@
     <p:sldId id="281" r:id="rId12"/>
     <p:sldId id="282" r:id="rId13"/>
     <p:sldId id="2221" r:id="rId14"/>
-    <p:sldId id="2236" r:id="rId15"/>
   </p:sldIdLst>
   <p:sldSz cx="12192000" cy="6858000"/>
   <p:notesSz cx="6858000" cy="9144000"/>
@@ -210,7 +209,7 @@
           <a:p>
             <a:fld id="{FB6042CB-28A2-754D-ACCB-4F0CF49EE203}" type="datetimeFigureOut">
               <a:rPr lang="en-US" smtClean="0"/>
-              <a:t>3/8/26</a:t>
+              <a:t>3/9/26</a:t>
             </a:fld>
             <a:endParaRPr lang="en-US"/>
           </a:p>
@@ -624,7 +623,7 @@
           <a:p>
             <a:fld id="{560296B3-6EEC-114C-BC37-B0B61E99771B}" type="datetimeFigureOut">
               <a:rPr lang="en-US" smtClean="0"/>
-              <a:t>3/8/26</a:t>
+              <a:t>3/9/26</a:t>
             </a:fld>
             <a:endParaRPr lang="en-US"/>
           </a:p>
@@ -822,7 +821,7 @@
           <a:p>
             <a:fld id="{560296B3-6EEC-114C-BC37-B0B61E99771B}" type="datetimeFigureOut">
               <a:rPr lang="en-US" smtClean="0"/>
-              <a:t>3/8/26</a:t>
+              <a:t>3/9/26</a:t>
             </a:fld>
             <a:endParaRPr lang="en-US"/>
           </a:p>
@@ -1030,7 +1029,7 @@
           <a:p>
             <a:fld id="{560296B3-6EEC-114C-BC37-B0B61E99771B}" type="datetimeFigureOut">
               <a:rPr lang="en-US" smtClean="0"/>
-              <a:t>3/8/26</a:t>
+              <a:t>3/9/26</a:t>
             </a:fld>
             <a:endParaRPr lang="en-US"/>
           </a:p>
@@ -1228,7 +1227,7 @@
           <a:p>
             <a:fld id="{560296B3-6EEC-114C-BC37-B0B61E99771B}" type="datetimeFigureOut">
               <a:rPr lang="en-US" smtClean="0"/>
-              <a:t>3/8/26</a:t>
+              <a:t>3/9/26</a:t>
             </a:fld>
             <a:endParaRPr lang="en-US"/>
           </a:p>
@@ -1503,7 +1502,7 @@
           <a:p>
             <a:fld id="{560296B3-6EEC-114C-BC37-B0B61E99771B}" type="datetimeFigureOut">
               <a:rPr lang="en-US" smtClean="0"/>
-              <a:t>3/8/26</a:t>
+              <a:t>3/9/26</a:t>
             </a:fld>
             <a:endParaRPr lang="en-US"/>
           </a:p>
@@ -1768,7 +1767,7 @@
           <a:p>
             <a:fld id="{560296B3-6EEC-114C-BC37-B0B61E99771B}" type="datetimeFigureOut">
               <a:rPr lang="en-US" smtClean="0"/>
-              <a:t>3/8/26</a:t>
+              <a:t>3/9/26</a:t>
             </a:fld>
             <a:endParaRPr lang="en-US"/>
           </a:p>
@@ -2180,7 +2179,7 @@
           <a:p>
             <a:fld id="{560296B3-6EEC-114C-BC37-B0B61E99771B}" type="datetimeFigureOut">
               <a:rPr lang="en-US" smtClean="0"/>
-              <a:t>3/8/26</a:t>
+              <a:t>3/9/26</a:t>
             </a:fld>
             <a:endParaRPr lang="en-US"/>
           </a:p>
@@ -2321,7 +2320,7 @@
           <a:p>
             <a:fld id="{560296B3-6EEC-114C-BC37-B0B61E99771B}" type="datetimeFigureOut">
               <a:rPr lang="en-US" smtClean="0"/>
-              <a:t>3/8/26</a:t>
+              <a:t>3/9/26</a:t>
             </a:fld>
             <a:endParaRPr lang="en-US"/>
           </a:p>
@@ -2434,7 +2433,7 @@
           <a:p>
             <a:fld id="{560296B3-6EEC-114C-BC37-B0B61E99771B}" type="datetimeFigureOut">
               <a:rPr lang="en-US" smtClean="0"/>
-              <a:t>3/8/26</a:t>
+              <a:t>3/9/26</a:t>
             </a:fld>
             <a:endParaRPr lang="en-US"/>
           </a:p>
@@ -2745,7 +2744,7 @@
           <a:p>
             <a:fld id="{560296B3-6EEC-114C-BC37-B0B61E99771B}" type="datetimeFigureOut">
               <a:rPr lang="en-US" smtClean="0"/>
-              <a:t>3/8/26</a:t>
+              <a:t>3/9/26</a:t>
             </a:fld>
             <a:endParaRPr lang="en-US"/>
           </a:p>
@@ -3033,7 +3032,7 @@
           <a:p>
             <a:fld id="{560296B3-6EEC-114C-BC37-B0B61E99771B}" type="datetimeFigureOut">
               <a:rPr lang="en-US" smtClean="0"/>
-              <a:t>3/8/26</a:t>
+              <a:t>3/9/26</a:t>
             </a:fld>
             <a:endParaRPr lang="en-US"/>
           </a:p>
@@ -3274,7 +3273,7 @@
           <a:p>
             <a:fld id="{560296B3-6EEC-114C-BC37-B0B61E99771B}" type="datetimeFigureOut">
               <a:rPr lang="en-US" smtClean="0"/>
-              <a:t>3/8/26</a:t>
+              <a:t>3/9/26</a:t>
             </a:fld>
             <a:endParaRPr lang="en-US"/>
           </a:p>
@@ -4941,183 +4940,6 @@
     <p:extLst>
       <p:ext uri="{BB962C8B-B14F-4D97-AF65-F5344CB8AC3E}">
         <p14:creationId xmlns:p14="http://schemas.microsoft.com/office/powerpoint/2010/main" val="1543468140"/>
-      </p:ext>
-    </p:extLst>
-  </p:cSld>
-  <p:clrMapOvr>
-    <a:masterClrMapping/>
-  </p:clrMapOvr>
-</p:sld>
-</file>
-
-<file path=ppt/slides/slide14.xml><?xml version="1.0" encoding="utf-8"?>
-<p:sld xmlns:a="http://schemas.openxmlformats.org/drawingml/2006/main" xmlns:r="http://schemas.openxmlformats.org/officeDocument/2006/relationships" xmlns:p="http://schemas.openxmlformats.org/presentationml/2006/main">
-  <p:cSld>
-    <p:spTree>
-      <p:nvGrpSpPr>
-        <p:cNvPr id="1" name="">
-          <a:extLst>
-            <a:ext uri="{FF2B5EF4-FFF2-40B4-BE49-F238E27FC236}">
-              <a16:creationId xmlns:a16="http://schemas.microsoft.com/office/drawing/2014/main" id="{408D7A66-6EBC-3016-5218-C3DB00C7AB72}"/>
-            </a:ext>
-          </a:extLst>
-        </p:cNvPr>
-        <p:cNvGrpSpPr/>
-        <p:nvPr/>
-      </p:nvGrpSpPr>
-      <p:grpSpPr>
-        <a:xfrm>
-          <a:off x="0" y="0"/>
-          <a:ext cx="0" cy="0"/>
-          <a:chOff x="0" y="0"/>
-          <a:chExt cx="0" cy="0"/>
-        </a:xfrm>
-      </p:grpSpPr>
-      <p:sp>
-        <p:nvSpPr>
-          <p:cNvPr id="2" name="TextBox 1">
-            <a:extLst>
-              <a:ext uri="{FF2B5EF4-FFF2-40B4-BE49-F238E27FC236}">
-                <a16:creationId xmlns:a16="http://schemas.microsoft.com/office/drawing/2014/main" id="{705158DD-527E-F619-EAE7-9B224C64E00B}"/>
-              </a:ext>
-            </a:extLst>
-          </p:cNvPr>
-          <p:cNvSpPr txBox="1"/>
-          <p:nvPr/>
-        </p:nvSpPr>
-        <p:spPr>
-          <a:xfrm>
-            <a:off x="657225" y="2533650"/>
-            <a:ext cx="10877550" cy="739754"/>
-          </a:xfrm>
-          <a:prstGeom prst="rect">
-            <a:avLst/>
-          </a:prstGeom>
-          <a:noFill/>
-        </p:spPr>
-        <p:txBody>
-          <a:bodyPr wrap="square" rtlCol="0">
-            <a:spAutoFit/>
-          </a:bodyPr>
-          <a:lstStyle/>
-          <a:p>
-            <a:pPr algn="ctr">
-              <a:lnSpc>
-                <a:spcPct val="150000"/>
-              </a:lnSpc>
-            </a:pPr>
-            <a:r>
-              <a:rPr lang="en-US" sz="3200" b="1" dirty="0">
-                <a:latin typeface="Arial" panose="020B0604020202020204" pitchFamily="34" charset="0"/>
-                <a:cs typeface="Arial" panose="020B0604020202020204" pitchFamily="34" charset="0"/>
-              </a:rPr>
-              <a:t>Poll </a:t>
-            </a:r>
-            <a:r>
-              <a:rPr lang="en-US" sz="3200" b="1" dirty="0">
-                <a:highlight>
-                  <a:srgbClr val="FFFF00"/>
-                </a:highlight>
-                <a:latin typeface="Arial" panose="020B0604020202020204" pitchFamily="34" charset="0"/>
-                <a:cs typeface="Arial" panose="020B0604020202020204" pitchFamily="34" charset="0"/>
-              </a:rPr>
-              <a:t>*after Sierra’s lecture</a:t>
-            </a:r>
-          </a:p>
-        </p:txBody>
-      </p:sp>
-      <p:sp>
-        <p:nvSpPr>
-          <p:cNvPr id="8" name="Slide Number Placeholder 7">
-            <a:extLst>
-              <a:ext uri="{FF2B5EF4-FFF2-40B4-BE49-F238E27FC236}">
-                <a16:creationId xmlns:a16="http://schemas.microsoft.com/office/drawing/2014/main" id="{2070759B-ED78-9239-C973-521BE427F44D}"/>
-              </a:ext>
-            </a:extLst>
-          </p:cNvPr>
-          <p:cNvSpPr>
-            <a:spLocks noGrp="1"/>
-          </p:cNvSpPr>
-          <p:nvPr>
-            <p:ph type="sldNum" sz="quarter" idx="12"/>
-          </p:nvPr>
-        </p:nvSpPr>
-        <p:spPr>
-          <a:xfrm>
-            <a:off x="9263062" y="6337300"/>
-            <a:ext cx="2743200" cy="365125"/>
-          </a:xfrm>
-        </p:spPr>
-        <p:txBody>
-          <a:bodyPr/>
-          <a:lstStyle/>
-          <a:p>
-            <a:fld id="{A7C13B74-2CD1-074C-84D2-FF26F00FE39E}" type="slidenum">
-              <a:rPr lang="en-US" sz="1400" smtClean="0">
-                <a:solidFill>
-                  <a:schemeClr val="tx1"/>
-                </a:solidFill>
-              </a:rPr>
-              <a:t>14</a:t>
-            </a:fld>
-            <a:endParaRPr lang="en-US" sz="1400" dirty="0">
-              <a:solidFill>
-                <a:schemeClr val="tx1"/>
-              </a:solidFill>
-            </a:endParaRPr>
-          </a:p>
-        </p:txBody>
-      </p:sp>
-      <p:sp>
-        <p:nvSpPr>
-          <p:cNvPr id="4" name="TextBox 3">
-            <a:extLst>
-              <a:ext uri="{FF2B5EF4-FFF2-40B4-BE49-F238E27FC236}">
-                <a16:creationId xmlns:a16="http://schemas.microsoft.com/office/drawing/2014/main" id="{01423887-CC8E-D16D-2E31-45CEFFEFBBE2}"/>
-              </a:ext>
-            </a:extLst>
-          </p:cNvPr>
-          <p:cNvSpPr txBox="1"/>
-          <p:nvPr/>
-        </p:nvSpPr>
-        <p:spPr>
-          <a:xfrm>
-            <a:off x="657225" y="3285541"/>
-            <a:ext cx="10877550" cy="598112"/>
-          </a:xfrm>
-          <a:prstGeom prst="rect">
-            <a:avLst/>
-          </a:prstGeom>
-          <a:noFill/>
-        </p:spPr>
-        <p:txBody>
-          <a:bodyPr wrap="square" rtlCol="0">
-            <a:spAutoFit/>
-          </a:bodyPr>
-          <a:lstStyle/>
-          <a:p>
-            <a:pPr algn="ctr">
-              <a:lnSpc>
-                <a:spcPct val="150000"/>
-              </a:lnSpc>
-            </a:pPr>
-            <a:r>
-              <a:rPr lang="en-US" sz="2500" dirty="0">
-                <a:highlight>
-                  <a:srgbClr val="FFFF00"/>
-                </a:highlight>
-                <a:latin typeface="Arial" panose="020B0604020202020204" pitchFamily="34" charset="0"/>
-                <a:cs typeface="Arial" panose="020B0604020202020204" pitchFamily="34" charset="0"/>
-              </a:rPr>
-              <a:t>[teams: level of understanding now vs before]</a:t>
-            </a:r>
-          </a:p>
-        </p:txBody>
-      </p:sp>
-    </p:spTree>
-    <p:extLst>
-      <p:ext uri="{BB962C8B-B14F-4D97-AF65-F5344CB8AC3E}">
-        <p14:creationId xmlns:p14="http://schemas.microsoft.com/office/powerpoint/2010/main" val="3182914858"/>
       </p:ext>
     </p:extLst>
   </p:cSld>

</xml_diff>